<commit_message>
Correct app sensitivity to 100% (Sorkin abstract) found by paper-reader skill check; add experiment log
</commit_message>
<xml_diff>
--- a/slides/cvd-screening-review.pptx
+++ b/slides/cvd-screening-review.pptx
@@ -3599,7 +3599,7 @@
               </a:defRPr>
             </a:pPr>
             <a:r>
-              <a:t>앱 특이도 최고 95.2% · 최저 54.8%  — Sorkin 2016</a:t>
+              <a:t>앱 특이도 최고 95.2% · 최저 54.8%, 민감도 100%  — Sorkin 2016</a:t>
             </a:r>
           </a:p>
           <a:p>
@@ -3628,7 +3628,23 @@
               </a:defRPr>
             </a:pPr>
             <a:r>
-              <a:t>가정(†): 인쇄판 특이도 95%, 앱 민감도 95.5% — 출처 없음, 명시함</a:t>
+              <a:t>가정(†): 인쇄판 특이도 95% — 출처 없음, 명시함</a:t>
+            </a:r>
+          </a:p>
+          <a:p>
+            <a:pPr>
+              <a:spcAft>
+                <a:spcPts val="600"/>
+              </a:spcAft>
+              <a:defRPr sz="2200" b="0">
+                <a:solidFill>
+                  <a:srgbClr val="1B1F24"/>
+                </a:solidFill>
+                <a:latin typeface="Malgun Gothic"/>
+              </a:defRPr>
+            </a:pPr>
+            <a:r>
+              <a:t>앱 성능은 이시하라 책자 대비 값(n=80)</a:t>
             </a:r>
           </a:p>
         </p:txBody>
@@ -3807,7 +3823,7 @@
               </a:defRPr>
             </a:pPr>
             <a:r>
-              <a:t>남성 PPV 12.8%†</a:t>
+              <a:t>남성 PPV 13.3%</a:t>
             </a:r>
           </a:p>
           <a:p>
@@ -3852,7 +3868,7 @@
               </a:defRPr>
             </a:pPr>
             <a:r>
-              <a:t>남성 PPV 58.0%†</a:t>
+              <a:t>남성 PPV 59.2%</a:t>
             </a:r>
           </a:p>
           <a:p>
@@ -3897,7 +3913,7 @@
               </a:defRPr>
             </a:pPr>
             <a:r>
-              <a:t>PPV 18.1%†</a:t>
+              <a:t>PPV 18.8%</a:t>
             </a:r>
           </a:p>
           <a:p>
@@ -4276,7 +4292,7 @@
               </a:defRPr>
             </a:pPr>
             <a:r>
-              <a:t>• 인쇄판 특이도·앱 민감도는 가정 — 결과에 조건부</a:t>
+              <a:t>• 인쇄판 특이도는 가정 · 앱 성능은 이시하라 대비(n=80)</a:t>
             </a:r>
           </a:p>
           <a:p>

</xml_diff>